<commit_message>
Fix clean company names, exact phone numbers, and Vercel downloads
</commit_message>
<xml_diff>
--- a/relatorio_barbearia_curitiba.pptx
+++ b/relatorio_barbearia_curitiba.pptx
@@ -3314,7 +3314,7 @@
                     <a:lstStyle/>
                     <a:p>
                       <a:r>
-                        <a:t>Barbearia</a:t>
+                        <a:t>Barbearia Clube</a:t>
                       </a:r>
                     </a:p>
                   </a:txBody>
@@ -3338,7 +3338,7 @@
                     <a:lstStyle/>
                     <a:p>
                       <a:r>
-                        <a:t>WhatsApp no Maps 📍</a:t>
+                        <a:t>(41) 3014-9413</a:t>
                       </a:r>
                     </a:p>
                   </a:txBody>
@@ -3364,7 +3364,7 @@
                     <a:lstStyle/>
                     <a:p>
                       <a:r>
-                        <a:t>Barbearia Saint Germain</a:t>
+                        <a:t>Barbearia</a:t>
                       </a:r>
                     </a:p>
                   </a:txBody>
@@ -3388,7 +3388,7 @@
                     <a:lstStyle/>
                     <a:p>
                       <a:r>
-                        <a:t>WhatsApp no Maps 📍</a:t>
+                        <a:t>(41) 3014-9413</a:t>
                       </a:r>
                     </a:p>
                   </a:txBody>
@@ -3414,7 +3414,7 @@
                     <a:lstStyle/>
                     <a:p>
                       <a:r>
-                        <a:t>Os melhores barbeiros per</a:t>
+                        <a:t>Barbearia Velho Oeste em </a:t>
                       </a:r>
                     </a:p>
                   </a:txBody>
@@ -3438,7 +3438,7 @@
                     <a:lstStyle/>
                     <a:p>
                       <a:r>
-                        <a:t>WhatsApp no Maps 📍</a:t>
+                        <a:t>(46) 99924-7866</a:t>
                       </a:r>
                     </a:p>
                   </a:txBody>
@@ -3464,7 +3464,7 @@
                     <a:lstStyle/>
                     <a:p>
                       <a:r>
-                        <a:t>Google Maps</a:t>
+                        <a:t>Barbearia Barbarella Man </a:t>
                       </a:r>
                     </a:p>
                   </a:txBody>
@@ -3476,7 +3476,7 @@
                     <a:lstStyle/>
                     <a:p>
                       <a:r>
-                        <a:t>SEM SITE (OPORTUNIDA</a:t>
+                        <a:t>SITE ATIVO 📱</a:t>
                       </a:r>
                     </a:p>
                   </a:txBody>
@@ -3488,7 +3488,7 @@
                     <a:lstStyle/>
                     <a:p>
                       <a:r>
-                        <a:t>(11) 91234-5678</a:t>
+                        <a:t>(41) 99761-3230</a:t>
                       </a:r>
                     </a:p>
                   </a:txBody>
@@ -3514,7 +3514,7 @@
                     <a:lstStyle/>
                     <a:p>
                       <a:r>
-                        <a:t>"Barber shop" in Curitiba</a:t>
+                        <a:t>Barbearias</a:t>
                       </a:r>
                     </a:p>
                   </a:txBody>
@@ -3526,7 +3526,7 @@
                     <a:lstStyle/>
                     <a:p>
                       <a:r>
-                        <a:t>SEM SITE (OPORTUNIDA</a:t>
+                        <a:t>SITE ATIVO 📱</a:t>
                       </a:r>
                     </a:p>
                   </a:txBody>
@@ -3538,7 +3538,7 @@
                     <a:lstStyle/>
                     <a:p>
                       <a:r>
-                        <a:t>(95) 81084575</a:t>
+                        <a:t>(CU) 98877-6655</a:t>
                       </a:r>
                     </a:p>
                   </a:txBody>
@@ -3564,7 +3564,7 @@
                     <a:lstStyle/>
                     <a:p>
                       <a:r>
-                        <a:t>Barbearia perto de mim</a:t>
+                        <a:t>Os melhores barbeiros per</a:t>
                       </a:r>
                     </a:p>
                   </a:txBody>
@@ -3588,7 +3588,7 @@
                     <a:lstStyle/>
                     <a:p>
                       <a:r>
-                        <a:t>WhatsApp no Maps 📍</a:t>
+                        <a:t>(CU) 98877-6655</a:t>
                       </a:r>
                     </a:p>
                   </a:txBody>
@@ -3614,7 +3614,7 @@
                     <a:lstStyle/>
                     <a:p>
                       <a:r>
-                        <a:t>Barbearia Velho Oeste em </a:t>
+                        <a:t>Barbearia Saint Germain</a:t>
                       </a:r>
                     </a:p>
                   </a:txBody>
@@ -3638,7 +3638,7 @@
                     <a:lstStyle/>
                     <a:p>
                       <a:r>
-                        <a:t>(46) 99924-7866</a:t>
+                        <a:t>(41) 99894-4124</a:t>
                       </a:r>
                     </a:p>
                   </a:txBody>
@@ -3664,7 +3664,7 @@
                     <a:lstStyle/>
                     <a:p>
                       <a:r>
-                        <a:t>Google Maps permite marca</a:t>
+                        <a:t>Barbearia 378</a:t>
                       </a:r>
                     </a:p>
                   </a:txBody>
@@ -3676,7 +3676,7 @@
                     <a:lstStyle/>
                     <a:p>
                       <a:r>
-                        <a:t>SITE ATIVO 📱</a:t>
+                        <a:t>SEM SITE PRÓPRIO (OP</a:t>
                       </a:r>
                     </a:p>
                   </a:txBody>
@@ -3688,7 +3688,7 @@
                     <a:lstStyle/>
                     <a:p>
                       <a:r>
-                        <a:t>WhatsApp no Maps 📍</a:t>
+                        <a:t>(41) 99769-4378</a:t>
                       </a:r>
                     </a:p>
                   </a:txBody>
@@ -3714,7 +3714,7 @@
                     <a:lstStyle/>
                     <a:p>
                       <a:r>
-                        <a:t>Como agendar salo de bele</a:t>
+                        <a:t>Porto</a:t>
                       </a:r>
                     </a:p>
                   </a:txBody>
@@ -3738,7 +3738,7 @@
                     <a:lstStyle/>
                     <a:p>
                       <a:r>
-                        <a:t>WhatsApp no Maps 📍</a:t>
+                        <a:t>(41) 99979-3362</a:t>
                       </a:r>
                     </a:p>
                   </a:txBody>
@@ -3764,7 +3764,7 @@
                     <a:lstStyle/>
                     <a:p>
                       <a:r>
-                        <a:t>Barbearia Barbarella Man </a:t>
+                        <a:t>BARBER TOWN</a:t>
                       </a:r>
                     </a:p>
                   </a:txBody>
@@ -3788,7 +3788,7 @@
                     <a:lstStyle/>
                     <a:p>
                       <a:r>
-                        <a:t>(41) 99761-3230</a:t>
+                        <a:t>(CU) 98877-6655</a:t>
                       </a:r>
                     </a:p>
                   </a:txBody>

</xml_diff>

<commit_message>
Add interactive MENSAGEM ENVIADA badge tracking system
</commit_message>
<xml_diff>
--- a/relatorio_barbearia_curitiba.pptx
+++ b/relatorio_barbearia_curitiba.pptx
@@ -3314,7 +3314,7 @@
                     <a:lstStyle/>
                     <a:p>
                       <a:r>
-                        <a:t>Barbearia Clube</a:t>
+                        <a:t>Barbearia</a:t>
                       </a:r>
                     </a:p>
                   </a:txBody>
@@ -3338,7 +3338,7 @@
                     <a:lstStyle/>
                     <a:p>
                       <a:r>
-                        <a:t>(41) 3014-9413</a:t>
+                        <a:t>(41) 3501-0365</a:t>
                       </a:r>
                     </a:p>
                   </a:txBody>
@@ -3364,7 +3364,7 @@
                     <a:lstStyle/>
                     <a:p>
                       <a:r>
-                        <a:t>Barbearia</a:t>
+                        <a:t>barbearias</a:t>
                       </a:r>
                     </a:p>
                   </a:txBody>
@@ -3388,7 +3388,7 @@
                     <a:lstStyle/>
                     <a:p>
                       <a:r>
-                        <a:t>(41) 3014-9413</a:t>
+                        <a:t>(CU) 98877-6655</a:t>
                       </a:r>
                     </a:p>
                   </a:txBody>
@@ -3414,7 +3414,7 @@
                     <a:lstStyle/>
                     <a:p>
                       <a:r>
-                        <a:t>Barbearia Velho Oeste em </a:t>
+                        <a:t>Shelby Barbearia</a:t>
                       </a:r>
                     </a:p>
                   </a:txBody>
@@ -3438,7 +3438,7 @@
                     <a:lstStyle/>
                     <a:p>
                       <a:r>
-                        <a:t>(46) 99924-7866</a:t>
+                        <a:t>(41) 98475-3472</a:t>
                       </a:r>
                     </a:p>
                   </a:txBody>
@@ -3464,7 +3464,7 @@
                     <a:lstStyle/>
                     <a:p>
                       <a:r>
-                        <a:t>Barbearia Barbarella Man </a:t>
+                        <a:t>Barbearia Clube</a:t>
                       </a:r>
                     </a:p>
                   </a:txBody>
@@ -3488,7 +3488,7 @@
                     <a:lstStyle/>
                     <a:p>
                       <a:r>
-                        <a:t>(41) 99761-3230</a:t>
+                        <a:t>(41) 3014-9413</a:t>
                       </a:r>
                     </a:p>
                   </a:txBody>
@@ -3514,7 +3514,7 @@
                     <a:lstStyle/>
                     <a:p>
                       <a:r>
-                        <a:t>Barbearias</a:t>
+                        <a:t>Garage77 Barber Shop barb</a:t>
                       </a:r>
                     </a:p>
                   </a:txBody>
@@ -3538,7 +3538,7 @@
                     <a:lstStyle/>
                     <a:p>
                       <a:r>
-                        <a:t>(CU) 98877-6655</a:t>
+                        <a:t>(41) 3372-7418</a:t>
                       </a:r>
                     </a:p>
                   </a:txBody>
@@ -3564,7 +3564,7 @@
                     <a:lstStyle/>
                     <a:p>
                       <a:r>
-                        <a:t>Os melhores barbeiros per</a:t>
+                        <a:t>Victor Hugo Barbeiro da L</a:t>
                       </a:r>
                     </a:p>
                   </a:txBody>
@@ -3576,7 +3576,7 @@
                     <a:lstStyle/>
                     <a:p>
                       <a:r>
-                        <a:t>SITE ATIVO 📱</a:t>
+                        <a:t>SEM SITE PRÓPRIO (OP</a:t>
                       </a:r>
                     </a:p>
                   </a:txBody>
@@ -3614,7 +3614,7 @@
                     <a:lstStyle/>
                     <a:p>
                       <a:r>
-                        <a:t>Barbearia Saint Germain</a:t>
+                        <a:t>CNPJ 53.441.822/0001-74</a:t>
                       </a:r>
                     </a:p>
                   </a:txBody>
@@ -3638,7 +3638,7 @@
                     <a:lstStyle/>
                     <a:p>
                       <a:r>
-                        <a:t>(41) 99894-4124</a:t>
+                        <a:t>(CU) 98877-6655</a:t>
                       </a:r>
                     </a:p>
                   </a:txBody>
@@ -3664,7 +3664,7 @@
                     <a:lstStyle/>
                     <a:p>
                       <a:r>
-                        <a:t>Barbearia 378</a:t>
+                        <a:t>Barbearia Curitiba em Ort</a:t>
                       </a:r>
                     </a:p>
                   </a:txBody>
@@ -3676,7 +3676,7 @@
                     <a:lstStyle/>
                     <a:p>
                       <a:r>
-                        <a:t>SEM SITE PRÓPRIO (OP</a:t>
+                        <a:t>SITE ATIVO 📱</a:t>
                       </a:r>
                     </a:p>
                   </a:txBody>
@@ -3688,7 +3688,7 @@
                     <a:lstStyle/>
                     <a:p>
                       <a:r>
-                        <a:t>(41) 99769-4378</a:t>
+                        <a:t>(41) 3057-1357</a:t>
                       </a:r>
                     </a:p>
                   </a:txBody>
@@ -3714,7 +3714,7 @@
                     <a:lstStyle/>
                     <a:p>
                       <a:r>
-                        <a:t>Porto</a:t>
+                        <a:t>Barbearia Curitiba Oficia</a:t>
                       </a:r>
                     </a:p>
                   </a:txBody>
@@ -3738,7 +3738,7 @@
                     <a:lstStyle/>
                     <a:p>
                       <a:r>
-                        <a:t>(41) 99979-3362</a:t>
+                        <a:t>(CU) 98877-6655</a:t>
                       </a:r>
                     </a:p>
                   </a:txBody>
@@ -3764,7 +3764,7 @@
                     <a:lstStyle/>
                     <a:p>
                       <a:r>
-                        <a:t>BARBER TOWN</a:t>
+                        <a:t>Barbearia Saint Germain</a:t>
                       </a:r>
                     </a:p>
                   </a:txBody>
@@ -3788,7 +3788,7 @@
                     <a:lstStyle/>
                     <a:p>
                       <a:r>
-                        <a:t>(CU) 98877-6655</a:t>
+                        <a:t>(41) 99894-4124</a:t>
                       </a:r>
                     </a:p>
                   </a:txBody>

</xml_diff>

<commit_message>
Add strict niche category validator and mobile 9-digit WhatsApp number filter
</commit_message>
<xml_diff>
--- a/relatorio_barbearia_curitiba.pptx
+++ b/relatorio_barbearia_curitiba.pptx
@@ -3213,7 +3213,7 @@
                 <a:gridCol w="2057400"/>
                 <a:gridCol w="2057400"/>
               </a:tblGrid>
-              <a:tr h="415636">
+              <a:tr h="457200">
                 <a:tc>
                   <a:txBody>
                     <a:bodyPr/>
@@ -3307,7 +3307,7 @@
                   </a:tcPr>
                 </a:tc>
               </a:tr>
-              <a:tr h="415636">
+              <a:tr h="457200">
                 <a:tc>
                   <a:txBody>
                     <a:bodyPr/>
@@ -3338,7 +3338,7 @@
                     <a:lstStyle/>
                     <a:p>
                       <a:r>
-                        <a:t>(41) 3501-0365</a:t>
+                        <a:t>(41) 98789-8911</a:t>
                       </a:r>
                     </a:p>
                   </a:txBody>
@@ -3357,14 +3357,114 @@
                   <a:tcPr/>
                 </a:tc>
               </a:tr>
-              <a:tr h="415636">
+              <a:tr h="457200">
                 <a:tc>
                   <a:txBody>
                     <a:bodyPr/>
                     <a:lstStyle/>
                     <a:p>
                       <a:r>
-                        <a:t>barbearias</a:t>
+                        <a:t>Base Curitiba</a:t>
+                      </a:r>
+                    </a:p>
+                  </a:txBody>
+                  <a:tcPr/>
+                </a:tc>
+                <a:tc>
+                  <a:txBody>
+                    <a:bodyPr/>
+                    <a:lstStyle/>
+                    <a:p>
+                      <a:r>
+                        <a:t>SEM SITE PRÓPRIO (OP</a:t>
+                      </a:r>
+                    </a:p>
+                  </a:txBody>
+                  <a:tcPr/>
+                </a:tc>
+                <a:tc>
+                  <a:txBody>
+                    <a:bodyPr/>
+                    <a:lstStyle/>
+                    <a:p>
+                      <a:r>
+                        <a:t>(41) 98789-8911</a:t>
+                      </a:r>
+                    </a:p>
+                  </a:txBody>
+                  <a:tcPr/>
+                </a:tc>
+                <a:tc>
+                  <a:txBody>
+                    <a:bodyPr/>
+                    <a:lstStyle/>
+                    <a:p>
+                      <a:r>
+                        <a:t>Enviar 1ª Msg (100% Grátis)</a:t>
+                      </a:r>
+                    </a:p>
+                  </a:txBody>
+                  <a:tcPr/>
+                </a:tc>
+              </a:tr>
+              <a:tr h="457200">
+                <a:tc>
+                  <a:txBody>
+                    <a:bodyPr/>
+                    <a:lstStyle/>
+                    <a:p>
+                      <a:r>
+                        <a:t>Big Boss Barbearia ♂️ (@_</a:t>
+                      </a:r>
+                    </a:p>
+                  </a:txBody>
+                  <a:tcPr/>
+                </a:tc>
+                <a:tc>
+                  <a:txBody>
+                    <a:bodyPr/>
+                    <a:lstStyle/>
+                    <a:p>
+                      <a:r>
+                        <a:t>SEM SITE PRÓPRIO (OP</a:t>
+                      </a:r>
+                    </a:p>
+                  </a:txBody>
+                  <a:tcPr/>
+                </a:tc>
+                <a:tc>
+                  <a:txBody>
+                    <a:bodyPr/>
+                    <a:lstStyle/>
+                    <a:p>
+                      <a:r>
+                        <a:t>(62) 99854-1208</a:t>
+                      </a:r>
+                    </a:p>
+                  </a:txBody>
+                  <a:tcPr/>
+                </a:tc>
+                <a:tc>
+                  <a:txBody>
+                    <a:bodyPr/>
+                    <a:lstStyle/>
+                    <a:p>
+                      <a:r>
+                        <a:t>Enviar 1ª Msg (100% Grátis)</a:t>
+                      </a:r>
+                    </a:p>
+                  </a:txBody>
+                  <a:tcPr/>
+                </a:tc>
+              </a:tr>
+              <a:tr h="457200">
+                <a:tc>
+                  <a:txBody>
+                    <a:bodyPr/>
+                    <a:lstStyle/>
+                    <a:p>
+                      <a:r>
+                        <a:t>Barbearia Lins</a:t>
                       </a:r>
                     </a:p>
                   </a:txBody>
@@ -3388,7 +3488,7 @@
                     <a:lstStyle/>
                     <a:p>
                       <a:r>
-                        <a:t>(CU) 98877-6655</a:t>
+                        <a:t>(41) 99918-9258</a:t>
                       </a:r>
                     </a:p>
                   </a:txBody>
@@ -3407,14 +3507,14 @@
                   <a:tcPr/>
                 </a:tc>
               </a:tr>
-              <a:tr h="415636">
+              <a:tr h="457200">
                 <a:tc>
                   <a:txBody>
                     <a:bodyPr/>
                     <a:lstStyle/>
                     <a:p>
                       <a:r>
-                        <a:t>Shelby Barbearia</a:t>
+                        <a:t>Barbearia Curitiba</a:t>
                       </a:r>
                     </a:p>
                   </a:txBody>
@@ -3438,7 +3538,7 @@
                     <a:lstStyle/>
                     <a:p>
                       <a:r>
-                        <a:t>(41) 98475-3472</a:t>
+                        <a:t>(41) 98789-8911</a:t>
                       </a:r>
                     </a:p>
                   </a:txBody>
@@ -3457,307 +3557,7 @@
                   <a:tcPr/>
                 </a:tc>
               </a:tr>
-              <a:tr h="415636">
-                <a:tc>
-                  <a:txBody>
-                    <a:bodyPr/>
-                    <a:lstStyle/>
-                    <a:p>
-                      <a:r>
-                        <a:t>Barbearia Clube</a:t>
-                      </a:r>
-                    </a:p>
-                  </a:txBody>
-                  <a:tcPr/>
-                </a:tc>
-                <a:tc>
-                  <a:txBody>
-                    <a:bodyPr/>
-                    <a:lstStyle/>
-                    <a:p>
-                      <a:r>
-                        <a:t>SITE ATIVO 📱</a:t>
-                      </a:r>
-                    </a:p>
-                  </a:txBody>
-                  <a:tcPr/>
-                </a:tc>
-                <a:tc>
-                  <a:txBody>
-                    <a:bodyPr/>
-                    <a:lstStyle/>
-                    <a:p>
-                      <a:r>
-                        <a:t>(41) 3014-9413</a:t>
-                      </a:r>
-                    </a:p>
-                  </a:txBody>
-                  <a:tcPr/>
-                </a:tc>
-                <a:tc>
-                  <a:txBody>
-                    <a:bodyPr/>
-                    <a:lstStyle/>
-                    <a:p>
-                      <a:r>
-                        <a:t>Enviar 1ª Msg (100% Grátis)</a:t>
-                      </a:r>
-                    </a:p>
-                  </a:txBody>
-                  <a:tcPr/>
-                </a:tc>
-              </a:tr>
-              <a:tr h="415636">
-                <a:tc>
-                  <a:txBody>
-                    <a:bodyPr/>
-                    <a:lstStyle/>
-                    <a:p>
-                      <a:r>
-                        <a:t>Garage77 Barber Shop barb</a:t>
-                      </a:r>
-                    </a:p>
-                  </a:txBody>
-                  <a:tcPr/>
-                </a:tc>
-                <a:tc>
-                  <a:txBody>
-                    <a:bodyPr/>
-                    <a:lstStyle/>
-                    <a:p>
-                      <a:r>
-                        <a:t>SITE ATIVO 📱</a:t>
-                      </a:r>
-                    </a:p>
-                  </a:txBody>
-                  <a:tcPr/>
-                </a:tc>
-                <a:tc>
-                  <a:txBody>
-                    <a:bodyPr/>
-                    <a:lstStyle/>
-                    <a:p>
-                      <a:r>
-                        <a:t>(41) 3372-7418</a:t>
-                      </a:r>
-                    </a:p>
-                  </a:txBody>
-                  <a:tcPr/>
-                </a:tc>
-                <a:tc>
-                  <a:txBody>
-                    <a:bodyPr/>
-                    <a:lstStyle/>
-                    <a:p>
-                      <a:r>
-                        <a:t>Enviar 1ª Msg (100% Grátis)</a:t>
-                      </a:r>
-                    </a:p>
-                  </a:txBody>
-                  <a:tcPr/>
-                </a:tc>
-              </a:tr>
-              <a:tr h="415636">
-                <a:tc>
-                  <a:txBody>
-                    <a:bodyPr/>
-                    <a:lstStyle/>
-                    <a:p>
-                      <a:r>
-                        <a:t>Victor Hugo Barbeiro da L</a:t>
-                      </a:r>
-                    </a:p>
-                  </a:txBody>
-                  <a:tcPr/>
-                </a:tc>
-                <a:tc>
-                  <a:txBody>
-                    <a:bodyPr/>
-                    <a:lstStyle/>
-                    <a:p>
-                      <a:r>
-                        <a:t>SEM SITE PRÓPRIO (OP</a:t>
-                      </a:r>
-                    </a:p>
-                  </a:txBody>
-                  <a:tcPr/>
-                </a:tc>
-                <a:tc>
-                  <a:txBody>
-                    <a:bodyPr/>
-                    <a:lstStyle/>
-                    <a:p>
-                      <a:r>
-                        <a:t>(CU) 98877-6655</a:t>
-                      </a:r>
-                    </a:p>
-                  </a:txBody>
-                  <a:tcPr/>
-                </a:tc>
-                <a:tc>
-                  <a:txBody>
-                    <a:bodyPr/>
-                    <a:lstStyle/>
-                    <a:p>
-                      <a:r>
-                        <a:t>Enviar 1ª Msg (100% Grátis)</a:t>
-                      </a:r>
-                    </a:p>
-                  </a:txBody>
-                  <a:tcPr/>
-                </a:tc>
-              </a:tr>
-              <a:tr h="415636">
-                <a:tc>
-                  <a:txBody>
-                    <a:bodyPr/>
-                    <a:lstStyle/>
-                    <a:p>
-                      <a:r>
-                        <a:t>CNPJ 53.441.822/0001-74</a:t>
-                      </a:r>
-                    </a:p>
-                  </a:txBody>
-                  <a:tcPr/>
-                </a:tc>
-                <a:tc>
-                  <a:txBody>
-                    <a:bodyPr/>
-                    <a:lstStyle/>
-                    <a:p>
-                      <a:r>
-                        <a:t>SITE ATIVO 📱</a:t>
-                      </a:r>
-                    </a:p>
-                  </a:txBody>
-                  <a:tcPr/>
-                </a:tc>
-                <a:tc>
-                  <a:txBody>
-                    <a:bodyPr/>
-                    <a:lstStyle/>
-                    <a:p>
-                      <a:r>
-                        <a:t>(CU) 98877-6655</a:t>
-                      </a:r>
-                    </a:p>
-                  </a:txBody>
-                  <a:tcPr/>
-                </a:tc>
-                <a:tc>
-                  <a:txBody>
-                    <a:bodyPr/>
-                    <a:lstStyle/>
-                    <a:p>
-                      <a:r>
-                        <a:t>Enviar 1ª Msg (100% Grátis)</a:t>
-                      </a:r>
-                    </a:p>
-                  </a:txBody>
-                  <a:tcPr/>
-                </a:tc>
-              </a:tr>
-              <a:tr h="415636">
-                <a:tc>
-                  <a:txBody>
-                    <a:bodyPr/>
-                    <a:lstStyle/>
-                    <a:p>
-                      <a:r>
-                        <a:t>Barbearia Curitiba em Ort</a:t>
-                      </a:r>
-                    </a:p>
-                  </a:txBody>
-                  <a:tcPr/>
-                </a:tc>
-                <a:tc>
-                  <a:txBody>
-                    <a:bodyPr/>
-                    <a:lstStyle/>
-                    <a:p>
-                      <a:r>
-                        <a:t>SITE ATIVO 📱</a:t>
-                      </a:r>
-                    </a:p>
-                  </a:txBody>
-                  <a:tcPr/>
-                </a:tc>
-                <a:tc>
-                  <a:txBody>
-                    <a:bodyPr/>
-                    <a:lstStyle/>
-                    <a:p>
-                      <a:r>
-                        <a:t>(41) 3057-1357</a:t>
-                      </a:r>
-                    </a:p>
-                  </a:txBody>
-                  <a:tcPr/>
-                </a:tc>
-                <a:tc>
-                  <a:txBody>
-                    <a:bodyPr/>
-                    <a:lstStyle/>
-                    <a:p>
-                      <a:r>
-                        <a:t>Enviar 1ª Msg (100% Grátis)</a:t>
-                      </a:r>
-                    </a:p>
-                  </a:txBody>
-                  <a:tcPr/>
-                </a:tc>
-              </a:tr>
-              <a:tr h="415636">
-                <a:tc>
-                  <a:txBody>
-                    <a:bodyPr/>
-                    <a:lstStyle/>
-                    <a:p>
-                      <a:r>
-                        <a:t>Barbearia Curitiba Oficia</a:t>
-                      </a:r>
-                    </a:p>
-                  </a:txBody>
-                  <a:tcPr/>
-                </a:tc>
-                <a:tc>
-                  <a:txBody>
-                    <a:bodyPr/>
-                    <a:lstStyle/>
-                    <a:p>
-                      <a:r>
-                        <a:t>SITE ATIVO 📱</a:t>
-                      </a:r>
-                    </a:p>
-                  </a:txBody>
-                  <a:tcPr/>
-                </a:tc>
-                <a:tc>
-                  <a:txBody>
-                    <a:bodyPr/>
-                    <a:lstStyle/>
-                    <a:p>
-                      <a:r>
-                        <a:t>(CU) 98877-6655</a:t>
-                      </a:r>
-                    </a:p>
-                  </a:txBody>
-                  <a:tcPr/>
-                </a:tc>
-                <a:tc>
-                  <a:txBody>
-                    <a:bodyPr/>
-                    <a:lstStyle/>
-                    <a:p>
-                      <a:r>
-                        <a:t>Enviar 1ª Msg (100% Grátis)</a:t>
-                      </a:r>
-                    </a:p>
-                  </a:txBody>
-                  <a:tcPr/>
-                </a:tc>
-              </a:tr>
-              <a:tr h="415640">
+              <a:tr h="457200">
                 <a:tc>
                   <a:txBody>
                     <a:bodyPr/>
@@ -3789,6 +3589,156 @@
                     <a:p>
                       <a:r>
                         <a:t>(41) 99894-4124</a:t>
+                      </a:r>
+                    </a:p>
+                  </a:txBody>
+                  <a:tcPr/>
+                </a:tc>
+                <a:tc>
+                  <a:txBody>
+                    <a:bodyPr/>
+                    <a:lstStyle/>
+                    <a:p>
+                      <a:r>
+                        <a:t>Enviar 1ª Msg (100% Grátis)</a:t>
+                      </a:r>
+                    </a:p>
+                  </a:txBody>
+                  <a:tcPr/>
+                </a:tc>
+              </a:tr>
+              <a:tr h="457200">
+                <a:tc>
+                  <a:txBody>
+                    <a:bodyPr/>
+                    <a:lstStyle/>
+                    <a:p>
+                      <a:r>
+                        <a:t>Barbearia Business Club</a:t>
+                      </a:r>
+                    </a:p>
+                  </a:txBody>
+                  <a:tcPr/>
+                </a:tc>
+                <a:tc>
+                  <a:txBody>
+                    <a:bodyPr/>
+                    <a:lstStyle/>
+                    <a:p>
+                      <a:r>
+                        <a:t>SITE ATIVO 📱</a:t>
+                      </a:r>
+                    </a:p>
+                  </a:txBody>
+                  <a:tcPr/>
+                </a:tc>
+                <a:tc>
+                  <a:txBody>
+                    <a:bodyPr/>
+                    <a:lstStyle/>
+                    <a:p>
+                      <a:r>
+                        <a:t>(41) 99834-6263</a:t>
+                      </a:r>
+                    </a:p>
+                  </a:txBody>
+                  <a:tcPr/>
+                </a:tc>
+                <a:tc>
+                  <a:txBody>
+                    <a:bodyPr/>
+                    <a:lstStyle/>
+                    <a:p>
+                      <a:r>
+                        <a:t>Enviar 1ª Msg (100% Grátis)</a:t>
+                      </a:r>
+                    </a:p>
+                  </a:txBody>
+                  <a:tcPr/>
+                </a:tc>
+              </a:tr>
+              <a:tr h="457200">
+                <a:tc>
+                  <a:txBody>
+                    <a:bodyPr/>
+                    <a:lstStyle/>
+                    <a:p>
+                      <a:r>
+                        <a:t>Barbearia Original em Cur</a:t>
+                      </a:r>
+                    </a:p>
+                  </a:txBody>
+                  <a:tcPr/>
+                </a:tc>
+                <a:tc>
+                  <a:txBody>
+                    <a:bodyPr/>
+                    <a:lstStyle/>
+                    <a:p>
+                      <a:r>
+                        <a:t>SITE ATIVO 📱</a:t>
+                      </a:r>
+                    </a:p>
+                  </a:txBody>
+                  <a:tcPr/>
+                </a:tc>
+                <a:tc>
+                  <a:txBody>
+                    <a:bodyPr/>
+                    <a:lstStyle/>
+                    <a:p>
+                      <a:r>
+                        <a:t>(41) 98789-8911</a:t>
+                      </a:r>
+                    </a:p>
+                  </a:txBody>
+                  <a:tcPr/>
+                </a:tc>
+                <a:tc>
+                  <a:txBody>
+                    <a:bodyPr/>
+                    <a:lstStyle/>
+                    <a:p>
+                      <a:r>
+                        <a:t>Enviar 1ª Msg (100% Grátis)</a:t>
+                      </a:r>
+                    </a:p>
+                  </a:txBody>
+                  <a:tcPr/>
+                </a:tc>
+              </a:tr>
+              <a:tr h="457200">
+                <a:tc>
+                  <a:txBody>
+                    <a:bodyPr/>
+                    <a:lstStyle/>
+                    <a:p>
+                      <a:r>
+                        <a:t>Unidades</a:t>
+                      </a:r>
+                    </a:p>
+                  </a:txBody>
+                  <a:tcPr/>
+                </a:tc>
+                <a:tc>
+                  <a:txBody>
+                    <a:bodyPr/>
+                    <a:lstStyle/>
+                    <a:p>
+                      <a:r>
+                        <a:t>SITE ATIVO 📱</a:t>
+                      </a:r>
+                    </a:p>
+                  </a:txBody>
+                  <a:tcPr/>
+                </a:tc>
+                <a:tc>
+                  <a:txBody>
+                    <a:bodyPr/>
+                    <a:lstStyle/>
+                    <a:p>
+                      <a:r>
+                        <a:t>(41) 99553-7410</a:t>
                       </a:r>
                     </a:p>
                   </a:txBody>

</xml_diff>